<commit_message>
slides for lectures 5 and 6 added
</commit_message>
<xml_diff>
--- a/lecture_slides/Week2_Lecture4_Reconstruction_Quantization_090326_forClass.pptx
+++ b/lecture_slides/Week2_Lecture4_Reconstruction_Quantization_090326_forClass.pptx
@@ -5,7 +5,7 @@
     <p:sldMasterId id="2147483648" r:id="rId1"/>
   </p:sldMasterIdLst>
   <p:notesMasterIdLst>
-    <p:notesMasterId r:id="rId29"/>
+    <p:notesMasterId r:id="rId30"/>
   </p:notesMasterIdLst>
   <p:sldIdLst>
     <p:sldId id="281" r:id="rId2"/>
@@ -29,12 +29,13 @@
     <p:sldId id="272" r:id="rId20"/>
     <p:sldId id="273" r:id="rId21"/>
     <p:sldId id="274" r:id="rId22"/>
-    <p:sldId id="275" r:id="rId23"/>
-    <p:sldId id="276" r:id="rId24"/>
-    <p:sldId id="277" r:id="rId25"/>
-    <p:sldId id="278" r:id="rId26"/>
-    <p:sldId id="280" r:id="rId27"/>
-    <p:sldId id="279" r:id="rId28"/>
+    <p:sldId id="283" r:id="rId23"/>
+    <p:sldId id="275" r:id="rId24"/>
+    <p:sldId id="276" r:id="rId25"/>
+    <p:sldId id="277" r:id="rId26"/>
+    <p:sldId id="278" r:id="rId27"/>
+    <p:sldId id="280" r:id="rId28"/>
+    <p:sldId id="279" r:id="rId29"/>
   </p:sldIdLst>
   <p:sldSz cx="12192000" cy="6858000"/>
   <p:notesSz cx="7315200" cy="9601200"/>
@@ -1399,7 +1400,13 @@
   <p:cSld>
     <p:spTree>
       <p:nvGrpSpPr>
-        <p:cNvPr id="1" name=""/>
+        <p:cNvPr id="1" name="">
+          <a:extLst>
+            <a:ext uri="{FF2B5EF4-FFF2-40B4-BE49-F238E27FC236}">
+              <a16:creationId xmlns:a16="http://schemas.microsoft.com/office/drawing/2014/main" id="{51B5791A-485C-2BF3-4FFB-F2B7FAE87B19}"/>
+            </a:ext>
+          </a:extLst>
+        </p:cNvPr>
         <p:cNvGrpSpPr/>
         <p:nvPr/>
       </p:nvGrpSpPr>
@@ -1413,7 +1420,13 @@
       </p:grpSpPr>
       <p:sp>
         <p:nvSpPr>
-          <p:cNvPr id="2" name="Slide Image Placeholder 1"/>
+          <p:cNvPr id="2" name="Slide Image Placeholder 1">
+            <a:extLst>
+              <a:ext uri="{FF2B5EF4-FFF2-40B4-BE49-F238E27FC236}">
+                <a16:creationId xmlns:a16="http://schemas.microsoft.com/office/drawing/2014/main" id="{B9E1C814-A12B-225E-F134-8769C13B1B4E}"/>
+              </a:ext>
+            </a:extLst>
+          </p:cNvPr>
           <p:cNvSpPr>
             <a:spLocks noGrp="1" noRot="1" noChangeAspect="1"/>
           </p:cNvSpPr>
@@ -1425,7 +1438,13 @@
       </p:sp>
       <p:sp>
         <p:nvSpPr>
-          <p:cNvPr id="3" name="Notes Placeholder 2"/>
+          <p:cNvPr id="3" name="Notes Placeholder 2">
+            <a:extLst>
+              <a:ext uri="{FF2B5EF4-FFF2-40B4-BE49-F238E27FC236}">
+                <a16:creationId xmlns:a16="http://schemas.microsoft.com/office/drawing/2014/main" id="{46DA40F2-EC79-6B1D-8AD4-465DE32708B6}"/>
+              </a:ext>
+            </a:extLst>
+          </p:cNvPr>
           <p:cNvSpPr>
             <a:spLocks noGrp="1"/>
           </p:cNvSpPr>
@@ -1447,7 +1466,13 @@
       </p:sp>
       <p:sp>
         <p:nvSpPr>
-          <p:cNvPr id="4" name="Slide Number Placeholder 3"/>
+          <p:cNvPr id="4" name="Slide Number Placeholder 3">
+            <a:extLst>
+              <a:ext uri="{FF2B5EF4-FFF2-40B4-BE49-F238E27FC236}">
+                <a16:creationId xmlns:a16="http://schemas.microsoft.com/office/drawing/2014/main" id="{4CE9BD0C-7A2F-405A-F9FB-FBB39BA601E4}"/>
+              </a:ext>
+            </a:extLst>
+          </p:cNvPr>
           <p:cNvSpPr>
             <a:spLocks noGrp="1"/>
           </p:cNvSpPr>
@@ -1471,7 +1496,7 @@
     </p:spTree>
     <p:extLst>
       <p:ext uri="{BB962C8B-B14F-4D97-AF65-F5344CB8AC3E}">
-        <p14:creationId xmlns:p14="http://schemas.microsoft.com/office/powerpoint/2010/main" val="1024086991"/>
+        <p14:creationId xmlns:p14="http://schemas.microsoft.com/office/powerpoint/2010/main" val="337219865"/>
       </p:ext>
     </p:extLst>
   </p:cSld>
@@ -1614,7 +1639,7 @@
           <a:p>
             <a:r>
               <a:rPr lang="en-US" dirty="0"/>
-              <a:t>[object Object]</a:t>
+              <a:t>[object Object],[object Object]</a:t>
             </a:r>
           </a:p>
         </p:txBody>
@@ -1747,6 +1772,93 @@
   <p:cSld>
     <p:spTree>
       <p:nvGrpSpPr>
+        <p:cNvPr id="1" name=""/>
+        <p:cNvGrpSpPr/>
+        <p:nvPr/>
+      </p:nvGrpSpPr>
+      <p:grpSpPr>
+        <a:xfrm>
+          <a:off x="0" y="0"/>
+          <a:ext cx="0" cy="0"/>
+          <a:chOff x="0" y="0"/>
+          <a:chExt cx="0" cy="0"/>
+        </a:xfrm>
+      </p:grpSpPr>
+      <p:sp>
+        <p:nvSpPr>
+          <p:cNvPr id="2" name="Slide Image Placeholder 1"/>
+          <p:cNvSpPr>
+            <a:spLocks noGrp="1" noRot="1" noChangeAspect="1"/>
+          </p:cNvSpPr>
+          <p:nvPr>
+            <p:ph type="sldImg"/>
+          </p:nvPr>
+        </p:nvSpPr>
+        <p:spPr/>
+      </p:sp>
+      <p:sp>
+        <p:nvSpPr>
+          <p:cNvPr id="3" name="Notes Placeholder 2"/>
+          <p:cNvSpPr>
+            <a:spLocks noGrp="1"/>
+          </p:cNvSpPr>
+          <p:nvPr>
+            <p:ph type="body" idx="1"/>
+          </p:nvPr>
+        </p:nvSpPr>
+        <p:spPr/>
+        <p:txBody>
+          <a:bodyPr/>
+          <a:lstStyle/>
+          <a:p>
+            <a:r>
+              <a:rPr lang="en-US" dirty="0"/>
+              <a:t>[object Object]</a:t>
+            </a:r>
+          </a:p>
+        </p:txBody>
+      </p:sp>
+      <p:sp>
+        <p:nvSpPr>
+          <p:cNvPr id="4" name="Slide Number Placeholder 3"/>
+          <p:cNvSpPr>
+            <a:spLocks noGrp="1"/>
+          </p:cNvSpPr>
+          <p:nvPr>
+            <p:ph type="sldNum" sz="quarter" idx="10"/>
+          </p:nvPr>
+        </p:nvSpPr>
+        <p:spPr/>
+        <p:txBody>
+          <a:bodyPr/>
+          <a:lstStyle/>
+          <a:p>
+            <a:fld id="{F7021451-1387-4CA6-816F-3879F97B5CBC}" type="slidenum">
+              <a:rPr lang="en-US"/>
+              <a:t>26</a:t>
+            </a:fld>
+            <a:endParaRPr lang="en-US"/>
+          </a:p>
+        </p:txBody>
+      </p:sp>
+    </p:spTree>
+    <p:extLst>
+      <p:ext uri="{BB962C8B-B14F-4D97-AF65-F5344CB8AC3E}">
+        <p14:creationId xmlns:p14="http://schemas.microsoft.com/office/powerpoint/2010/main" val="1024086991"/>
+      </p:ext>
+    </p:extLst>
+  </p:cSld>
+  <p:clrMapOvr>
+    <a:masterClrMapping/>
+  </p:clrMapOvr>
+</p:notes>
+</file>
+
+<file path=ppt/notesSlides/notesSlide26.xml><?xml version="1.0" encoding="utf-8"?>
+<p:notes xmlns:a="http://schemas.openxmlformats.org/drawingml/2006/main" xmlns:r="http://schemas.openxmlformats.org/officeDocument/2006/relationships" xmlns:p="http://schemas.openxmlformats.org/presentationml/2006/main">
+  <p:cSld>
+    <p:spTree>
+      <p:nvGrpSpPr>
         <p:cNvPr id="1" name="">
           <a:extLst>
             <a:ext uri="{FF2B5EF4-FFF2-40B4-BE49-F238E27FC236}">
@@ -1834,7 +1946,7 @@
           <a:p>
             <a:fld id="{F7021451-1387-4CA6-816F-3879F97B5CBC}" type="slidenum">
               <a:rPr lang="en-US"/>
-              <a:t>26</a:t>
+              <a:t>27</a:t>
             </a:fld>
             <a:endParaRPr lang="en-US"/>
           </a:p>
@@ -1853,7 +1965,7 @@
 </p:notes>
 </file>
 
-<file path=ppt/notesSlides/notesSlide26.xml><?xml version="1.0" encoding="utf-8"?>
+<file path=ppt/notesSlides/notesSlide27.xml><?xml version="1.0" encoding="utf-8"?>
 <p:notes xmlns:a="http://schemas.openxmlformats.org/drawingml/2006/main" xmlns:r="http://schemas.openxmlformats.org/officeDocument/2006/relationships" xmlns:p="http://schemas.openxmlformats.org/presentationml/2006/main">
   <p:cSld>
     <p:spTree>
@@ -1921,7 +2033,7 @@
           <a:p>
             <a:fld id="{F7021451-1387-4CA6-816F-3879F97B5CBC}" type="slidenum">
               <a:rPr lang="en-US"/>
-              <a:t>27</a:t>
+              <a:t>28</a:t>
             </a:fld>
             <a:endParaRPr lang="en-US"/>
           </a:p>
@@ -2725,7 +2837,7 @@
           </a:prstGeom>
           <a:extLst>
             <a:ext uri="{C572A759-6A51-4108-AA02-DFA0A04FC94B}">
-              <ma14:wrappingTextBoxFlag xmlns="" xmlns:ma14="http://schemas.microsoft.com/office/mac/drawingml/2011/main" val="0"/>
+              <ma14:wrappingTextBoxFlag xmlns:ma14="http://schemas.microsoft.com/office/mac/drawingml/2011/main" xmlns="" val="0"/>
             </a:ext>
           </a:extLst>
         </p:spPr>
@@ -2803,7 +2915,7 @@
           </a:prstGeom>
           <a:extLst>
             <a:ext uri="{C572A759-6A51-4108-AA02-DFA0A04FC94B}">
-              <ma14:wrappingTextBoxFlag xmlns="" xmlns:ma14="http://schemas.microsoft.com/office/mac/drawingml/2011/main" val="0"/>
+              <ma14:wrappingTextBoxFlag xmlns:ma14="http://schemas.microsoft.com/office/mac/drawingml/2011/main" xmlns="" val="0"/>
             </a:ext>
           </a:extLst>
         </p:spPr>
@@ -3691,7 +3803,7 @@
           </a:prstGeom>
           <a:extLst>
             <a:ext uri="{C572A759-6A51-4108-AA02-DFA0A04FC94B}">
-              <ma14:wrappingTextBoxFlag xmlns="" xmlns:ma14="http://schemas.microsoft.com/office/mac/drawingml/2011/main" val="0"/>
+              <ma14:wrappingTextBoxFlag xmlns:ma14="http://schemas.microsoft.com/office/mac/drawingml/2011/main" xmlns="" val="0"/>
             </a:ext>
           </a:extLst>
         </p:spPr>
@@ -4040,7 +4152,7 @@
           </a:prstGeom>
           <a:extLst>
             <a:ext uri="{C572A759-6A51-4108-AA02-DFA0A04FC94B}">
-              <ma14:wrappingTextBoxFlag xmlns="" xmlns:ma14="http://schemas.microsoft.com/office/mac/drawingml/2011/main" val="0"/>
+              <ma14:wrappingTextBoxFlag xmlns:ma14="http://schemas.microsoft.com/office/mac/drawingml/2011/main" xmlns="" val="0"/>
             </a:ext>
           </a:extLst>
         </p:spPr>
@@ -4441,7 +4553,7 @@
           </a:prstGeom>
           <a:extLst>
             <a:ext uri="{C572A759-6A51-4108-AA02-DFA0A04FC94B}">
-              <ma14:wrappingTextBoxFlag xmlns="" xmlns:ma14="http://schemas.microsoft.com/office/mac/drawingml/2011/main" val="0"/>
+              <ma14:wrappingTextBoxFlag xmlns:ma14="http://schemas.microsoft.com/office/mac/drawingml/2011/main" xmlns="" val="0"/>
             </a:ext>
           </a:extLst>
         </p:spPr>
@@ -4689,7 +4801,7 @@
           </a:prstGeom>
           <a:extLst>
             <a:ext uri="{C572A759-6A51-4108-AA02-DFA0A04FC94B}">
-              <ma14:wrappingTextBoxFlag xmlns="" xmlns:ma14="http://schemas.microsoft.com/office/mac/drawingml/2011/main" val="0"/>
+              <ma14:wrappingTextBoxFlag xmlns:ma14="http://schemas.microsoft.com/office/mac/drawingml/2011/main" xmlns="" val="0"/>
             </a:ext>
           </a:extLst>
         </p:spPr>
@@ -5376,7 +5488,7 @@
           </a:prstGeom>
           <a:extLst>
             <a:ext uri="{C572A759-6A51-4108-AA02-DFA0A04FC94B}">
-              <ma14:wrappingTextBoxFlag xmlns="" xmlns:ma14="http://schemas.microsoft.com/office/mac/drawingml/2011/main" val="0"/>
+              <ma14:wrappingTextBoxFlag xmlns:ma14="http://schemas.microsoft.com/office/mac/drawingml/2011/main" xmlns="" val="0"/>
             </a:ext>
           </a:extLst>
         </p:spPr>
@@ -5721,7 +5833,7 @@
           </a:prstGeom>
           <a:extLst>
             <a:ext uri="{C572A759-6A51-4108-AA02-DFA0A04FC94B}">
-              <ma14:wrappingTextBoxFlag xmlns="" xmlns:ma14="http://schemas.microsoft.com/office/mac/drawingml/2011/main" val="0"/>
+              <ma14:wrappingTextBoxFlag xmlns:ma14="http://schemas.microsoft.com/office/mac/drawingml/2011/main" xmlns="" val="0"/>
             </a:ext>
           </a:extLst>
         </p:spPr>
@@ -6100,7 +6212,7 @@
           </a:prstGeom>
           <a:extLst>
             <a:ext uri="{C572A759-6A51-4108-AA02-DFA0A04FC94B}">
-              <ma14:wrappingTextBoxFlag xmlns="" xmlns:ma14="http://schemas.microsoft.com/office/mac/drawingml/2011/main" val="0"/>
+              <ma14:wrappingTextBoxFlag xmlns:ma14="http://schemas.microsoft.com/office/mac/drawingml/2011/main" xmlns="" val="0"/>
             </a:ext>
           </a:extLst>
         </p:spPr>
@@ -6425,7 +6537,7 @@
           </a:prstGeom>
           <a:extLst>
             <a:ext uri="{C572A759-6A51-4108-AA02-DFA0A04FC94B}">
-              <ma14:wrappingTextBoxFlag xmlns="" xmlns:ma14="http://schemas.microsoft.com/office/mac/drawingml/2011/main" val="0"/>
+              <ma14:wrappingTextBoxFlag xmlns:ma14="http://schemas.microsoft.com/office/mac/drawingml/2011/main" xmlns="" val="0"/>
             </a:ext>
           </a:extLst>
         </p:spPr>
@@ -6814,7 +6926,7 @@
           </a:prstGeom>
           <a:extLst>
             <a:ext uri="{C572A759-6A51-4108-AA02-DFA0A04FC94B}">
-              <ma14:wrappingTextBoxFlag xmlns="" xmlns:ma14="http://schemas.microsoft.com/office/mac/drawingml/2011/main" val="0"/>
+              <ma14:wrappingTextBoxFlag xmlns:ma14="http://schemas.microsoft.com/office/mac/drawingml/2011/main" xmlns="" val="0"/>
             </a:ext>
           </a:extLst>
         </p:spPr>
@@ -7149,7 +7261,7 @@
           </a:prstGeom>
           <a:extLst>
             <a:ext uri="{C572A759-6A51-4108-AA02-DFA0A04FC94B}">
-              <ma14:wrappingTextBoxFlag xmlns="" xmlns:ma14="http://schemas.microsoft.com/office/mac/drawingml/2011/main" val="0"/>
+              <ma14:wrappingTextBoxFlag xmlns:ma14="http://schemas.microsoft.com/office/mac/drawingml/2011/main" xmlns="" val="0"/>
             </a:ext>
           </a:extLst>
         </p:spPr>
@@ -7493,7 +7605,7 @@
           </a:prstGeom>
           <a:extLst>
             <a:ext uri="{C572A759-6A51-4108-AA02-DFA0A04FC94B}">
-              <ma14:wrappingTextBoxFlag xmlns="" xmlns:ma14="http://schemas.microsoft.com/office/mac/drawingml/2011/main" val="0"/>
+              <ma14:wrappingTextBoxFlag xmlns:ma14="http://schemas.microsoft.com/office/mac/drawingml/2011/main" xmlns="" val="0"/>
             </a:ext>
           </a:extLst>
         </p:spPr>
@@ -8083,7 +8195,7 @@
           </a:prstGeom>
           <a:extLst>
             <a:ext uri="{C572A759-6A51-4108-AA02-DFA0A04FC94B}">
-              <ma14:wrappingTextBoxFlag xmlns="" xmlns:ma14="http://schemas.microsoft.com/office/mac/drawingml/2011/main" val="0"/>
+              <ma14:wrappingTextBoxFlag xmlns:ma14="http://schemas.microsoft.com/office/mac/drawingml/2011/main" xmlns="" val="0"/>
             </a:ext>
           </a:extLst>
         </p:spPr>
@@ -8532,7 +8644,7 @@
           </a:prstGeom>
           <a:extLst>
             <a:ext uri="{C572A759-6A51-4108-AA02-DFA0A04FC94B}">
-              <ma14:wrappingTextBoxFlag xmlns="" xmlns:ma14="http://schemas.microsoft.com/office/mac/drawingml/2011/main" val="0"/>
+              <ma14:wrappingTextBoxFlag xmlns:ma14="http://schemas.microsoft.com/office/mac/drawingml/2011/main" xmlns="" val="0"/>
             </a:ext>
           </a:extLst>
         </p:spPr>
@@ -8569,6 +8681,956 @@
 </file>
 
 <file path=ppt/slides/slide22.xml><?xml version="1.0" encoding="utf-8"?>
+<p:sld xmlns:a="http://schemas.openxmlformats.org/drawingml/2006/main" xmlns:r="http://schemas.openxmlformats.org/officeDocument/2006/relationships" xmlns:p="http://schemas.openxmlformats.org/presentationml/2006/main">
+  <p:cSld>
+    <p:spTree>
+      <p:nvGrpSpPr>
+        <p:cNvPr id="1" name="">
+          <a:extLst>
+            <a:ext uri="{FF2B5EF4-FFF2-40B4-BE49-F238E27FC236}">
+              <a16:creationId xmlns:a16="http://schemas.microsoft.com/office/drawing/2014/main" id="{B95014A7-F089-9479-1F95-04134F22939F}"/>
+            </a:ext>
+          </a:extLst>
+        </p:cNvPr>
+        <p:cNvGrpSpPr/>
+        <p:nvPr/>
+      </p:nvGrpSpPr>
+      <p:grpSpPr>
+        <a:xfrm>
+          <a:off x="0" y="0"/>
+          <a:ext cx="0" cy="0"/>
+          <a:chOff x="0" y="0"/>
+          <a:chExt cx="0" cy="0"/>
+        </a:xfrm>
+      </p:grpSpPr>
+      <p:sp>
+        <p:nvSpPr>
+          <p:cNvPr id="2" name="Text 0">
+            <a:extLst>
+              <a:ext uri="{FF2B5EF4-FFF2-40B4-BE49-F238E27FC236}">
+                <a16:creationId xmlns:a16="http://schemas.microsoft.com/office/drawing/2014/main" id="{85E0DF6C-A2A7-FD7C-2108-89EA1810D7D4}"/>
+              </a:ext>
+            </a:extLst>
+          </p:cNvPr>
+          <p:cNvSpPr/>
+          <p:nvPr/>
+        </p:nvSpPr>
+        <p:spPr>
+          <a:xfrm>
+            <a:off x="566928" y="384048"/>
+            <a:ext cx="11018520" cy="457200"/>
+          </a:xfrm>
+          <a:prstGeom prst="rect">
+            <a:avLst/>
+          </a:prstGeom>
+          <a:noFill/>
+          <a:ln/>
+        </p:spPr>
+        <p:txBody>
+          <a:bodyPr wrap="square" lIns="0" tIns="0" rIns="0" bIns="0" rtlCol="0" anchor="ctr"/>
+          <a:lstStyle/>
+          <a:p>
+            <a:pPr marL="0" indent="0">
+              <a:buNone/>
+            </a:pPr>
+            <a:r>
+              <a:rPr lang="en-US" sz="3000" b="1" dirty="0">
+                <a:solidFill>
+                  <a:srgbClr val="16324F"/>
+                </a:solidFill>
+                <a:latin typeface="Aptos" pitchFamily="34" charset="0"/>
+                <a:ea typeface="Aptos" pitchFamily="34" charset="-122"/>
+                <a:cs typeface="Aptos" pitchFamily="34" charset="-120"/>
+              </a:rPr>
+              <a:t>Live audio demo: listen in this order</a:t>
+            </a:r>
+            <a:endParaRPr lang="en-US" sz="3000" dirty="0"/>
+          </a:p>
+        </p:txBody>
+      </p:sp>
+      <p:sp>
+        <p:nvSpPr>
+          <p:cNvPr id="3" name="Text 1">
+            <a:extLst>
+              <a:ext uri="{FF2B5EF4-FFF2-40B4-BE49-F238E27FC236}">
+                <a16:creationId xmlns:a16="http://schemas.microsoft.com/office/drawing/2014/main" id="{A54FC120-B5E6-AE5E-BB85-E5FE02B17EA6}"/>
+              </a:ext>
+            </a:extLst>
+          </p:cNvPr>
+          <p:cNvSpPr/>
+          <p:nvPr/>
+        </p:nvSpPr>
+        <p:spPr>
+          <a:xfrm>
+            <a:off x="594360" y="886968"/>
+            <a:ext cx="10789920" cy="310896"/>
+          </a:xfrm>
+          <a:prstGeom prst="rect">
+            <a:avLst/>
+          </a:prstGeom>
+          <a:noFill/>
+          <a:ln/>
+        </p:spPr>
+        <p:txBody>
+          <a:bodyPr wrap="square" lIns="0" tIns="0" rIns="0" bIns="0" rtlCol="0" anchor="ctr"/>
+          <a:lstStyle/>
+          <a:p>
+            <a:pPr marL="0" indent="0">
+              <a:buNone/>
+            </a:pPr>
+            <a:r>
+              <a:rPr lang="en-US" sz="1550" dirty="0">
+                <a:solidFill>
+                  <a:srgbClr val="53616E"/>
+                </a:solidFill>
+                <a:latin typeface="Aptos" pitchFamily="34" charset="0"/>
+                <a:ea typeface="Aptos" pitchFamily="34" charset="-122"/>
+                <a:cs typeface="Aptos" pitchFamily="34" charset="-120"/>
+              </a:rPr>
+              <a:t>The package includes pre-generated WAV files and notebook code.</a:t>
+            </a:r>
+            <a:endParaRPr lang="en-US" sz="1550" dirty="0"/>
+          </a:p>
+        </p:txBody>
+      </p:sp>
+      <p:sp>
+        <p:nvSpPr>
+          <p:cNvPr id="4" name="Shape 2">
+            <a:extLst>
+              <a:ext uri="{FF2B5EF4-FFF2-40B4-BE49-F238E27FC236}">
+                <a16:creationId xmlns:a16="http://schemas.microsoft.com/office/drawing/2014/main" id="{02BDC1C6-595B-C85B-CE8A-D9DF611759F1}"/>
+              </a:ext>
+            </a:extLst>
+          </p:cNvPr>
+          <p:cNvSpPr/>
+          <p:nvPr/>
+        </p:nvSpPr>
+        <p:spPr>
+          <a:xfrm>
+            <a:off x="777240" y="1234440"/>
+            <a:ext cx="502920" cy="502920"/>
+          </a:xfrm>
+          <a:prstGeom prst="ellipse">
+            <a:avLst/>
+          </a:prstGeom>
+          <a:solidFill>
+            <a:srgbClr val="00A6A6"/>
+          </a:solidFill>
+          <a:ln w="12700">
+            <a:solidFill>
+              <a:srgbClr val="FFFFFF"/>
+            </a:solidFill>
+            <a:prstDash val="solid"/>
+          </a:ln>
+        </p:spPr>
+        <p:txBody>
+          <a:bodyPr/>
+          <a:lstStyle/>
+          <a:p>
+            <a:endParaRPr lang="en-US"/>
+          </a:p>
+        </p:txBody>
+      </p:sp>
+      <p:sp>
+        <p:nvSpPr>
+          <p:cNvPr id="5" name="Text 3">
+            <a:extLst>
+              <a:ext uri="{FF2B5EF4-FFF2-40B4-BE49-F238E27FC236}">
+                <a16:creationId xmlns:a16="http://schemas.microsoft.com/office/drawing/2014/main" id="{16903BA3-0725-11C1-4D94-63F5DA0BCD9E}"/>
+              </a:ext>
+            </a:extLst>
+          </p:cNvPr>
+          <p:cNvSpPr/>
+          <p:nvPr/>
+        </p:nvSpPr>
+        <p:spPr>
+          <a:xfrm>
+            <a:off x="777240" y="1353312"/>
+            <a:ext cx="502920" cy="201168"/>
+          </a:xfrm>
+          <a:prstGeom prst="rect">
+            <a:avLst/>
+          </a:prstGeom>
+          <a:noFill/>
+          <a:ln/>
+        </p:spPr>
+        <p:txBody>
+          <a:bodyPr wrap="square" lIns="0" tIns="0" rIns="0" bIns="0" rtlCol="0" anchor="ctr"/>
+          <a:lstStyle/>
+          <a:p>
+            <a:pPr marL="0" indent="0" algn="ctr">
+              <a:buNone/>
+            </a:pPr>
+            <a:r>
+              <a:rPr lang="en-US" sz="1400" b="1" dirty="0">
+                <a:solidFill>
+                  <a:srgbClr val="FFFFFF"/>
+                </a:solidFill>
+                <a:latin typeface="Aptos" pitchFamily="34" charset="0"/>
+                <a:ea typeface="Aptos" pitchFamily="34" charset="-122"/>
+                <a:cs typeface="Aptos" pitchFamily="34" charset="-120"/>
+              </a:rPr>
+              <a:t>1</a:t>
+            </a:r>
+            <a:endParaRPr lang="en-US" sz="1400" dirty="0"/>
+          </a:p>
+        </p:txBody>
+      </p:sp>
+      <p:sp>
+        <p:nvSpPr>
+          <p:cNvPr id="6" name="Text 4">
+            <a:extLst>
+              <a:ext uri="{FF2B5EF4-FFF2-40B4-BE49-F238E27FC236}">
+                <a16:creationId xmlns:a16="http://schemas.microsoft.com/office/drawing/2014/main" id="{90D0B0C5-3047-AFE8-C5F7-4C457565B81C}"/>
+              </a:ext>
+            </a:extLst>
+          </p:cNvPr>
+          <p:cNvSpPr/>
+          <p:nvPr/>
+        </p:nvSpPr>
+        <p:spPr>
+          <a:xfrm>
+            <a:off x="1508760" y="1261872"/>
+            <a:ext cx="2926080" cy="256032"/>
+          </a:xfrm>
+          <a:prstGeom prst="rect">
+            <a:avLst/>
+          </a:prstGeom>
+          <a:noFill/>
+          <a:ln/>
+        </p:spPr>
+        <p:txBody>
+          <a:bodyPr wrap="square" lIns="0" tIns="0" rIns="0" bIns="0" rtlCol="0" anchor="ctr"/>
+          <a:lstStyle/>
+          <a:p>
+            <a:pPr marL="0" indent="0">
+              <a:buNone/>
+            </a:pPr>
+            <a:r>
+              <a:rPr lang="en-US" sz="2000" b="1" dirty="0">
+                <a:solidFill>
+                  <a:srgbClr val="16324F"/>
+                </a:solidFill>
+                <a:latin typeface="Aptos" pitchFamily="34" charset="0"/>
+                <a:ea typeface="Aptos" pitchFamily="34" charset="-122"/>
+                <a:cs typeface="Aptos" pitchFamily="34" charset="-120"/>
+              </a:rPr>
+              <a:t>Clean 48 kHz</a:t>
+            </a:r>
+            <a:endParaRPr lang="en-US" sz="2000" dirty="0"/>
+          </a:p>
+        </p:txBody>
+      </p:sp>
+      <p:sp>
+        <p:nvSpPr>
+          <p:cNvPr id="7" name="Text 5">
+            <a:extLst>
+              <a:ext uri="{FF2B5EF4-FFF2-40B4-BE49-F238E27FC236}">
+                <a16:creationId xmlns:a16="http://schemas.microsoft.com/office/drawing/2014/main" id="{0EAED76A-F3CB-F127-E62A-FE9910A00A9F}"/>
+              </a:ext>
+            </a:extLst>
+          </p:cNvPr>
+          <p:cNvSpPr/>
+          <p:nvPr/>
+        </p:nvSpPr>
+        <p:spPr>
+          <a:xfrm>
+            <a:off x="4572000" y="1280160"/>
+            <a:ext cx="5943600" cy="256032"/>
+          </a:xfrm>
+          <a:prstGeom prst="rect">
+            <a:avLst/>
+          </a:prstGeom>
+          <a:noFill/>
+          <a:ln/>
+        </p:spPr>
+        <p:txBody>
+          <a:bodyPr wrap="square" lIns="0" tIns="0" rIns="0" bIns="0" rtlCol="0" anchor="ctr"/>
+          <a:lstStyle/>
+          <a:p>
+            <a:pPr marL="0" indent="0">
+              <a:buNone/>
+            </a:pPr>
+            <a:r>
+              <a:rPr lang="en-US" sz="1800" dirty="0">
+                <a:solidFill>
+                  <a:srgbClr val="53616E"/>
+                </a:solidFill>
+                <a:latin typeface="Aptos" pitchFamily="34" charset="0"/>
+                <a:ea typeface="Aptos" pitchFamily="34" charset="-122"/>
+                <a:cs typeface="Aptos" pitchFamily="34" charset="-120"/>
+              </a:rPr>
+              <a:t>reference</a:t>
+            </a:r>
+            <a:endParaRPr lang="en-US" sz="1800" dirty="0"/>
+          </a:p>
+        </p:txBody>
+      </p:sp>
+      <p:sp>
+        <p:nvSpPr>
+          <p:cNvPr id="8" name="Shape 6">
+            <a:extLst>
+              <a:ext uri="{FF2B5EF4-FFF2-40B4-BE49-F238E27FC236}">
+                <a16:creationId xmlns:a16="http://schemas.microsoft.com/office/drawing/2014/main" id="{D881A843-1742-6565-857F-B56821646C6F}"/>
+              </a:ext>
+            </a:extLst>
+          </p:cNvPr>
+          <p:cNvSpPr/>
+          <p:nvPr/>
+        </p:nvSpPr>
+        <p:spPr>
+          <a:xfrm>
+            <a:off x="777240" y="2075688"/>
+            <a:ext cx="502920" cy="502920"/>
+          </a:xfrm>
+          <a:prstGeom prst="ellipse">
+            <a:avLst/>
+          </a:prstGeom>
+          <a:solidFill>
+            <a:srgbClr val="D84A3A"/>
+          </a:solidFill>
+          <a:ln w="12700">
+            <a:solidFill>
+              <a:srgbClr val="FFFFFF"/>
+            </a:solidFill>
+            <a:prstDash val="solid"/>
+          </a:ln>
+        </p:spPr>
+        <p:txBody>
+          <a:bodyPr/>
+          <a:lstStyle/>
+          <a:p>
+            <a:endParaRPr lang="en-US"/>
+          </a:p>
+        </p:txBody>
+      </p:sp>
+      <p:sp>
+        <p:nvSpPr>
+          <p:cNvPr id="9" name="Text 7">
+            <a:extLst>
+              <a:ext uri="{FF2B5EF4-FFF2-40B4-BE49-F238E27FC236}">
+                <a16:creationId xmlns:a16="http://schemas.microsoft.com/office/drawing/2014/main" id="{C859AC50-CA38-B9BF-50CA-32028768116C}"/>
+              </a:ext>
+            </a:extLst>
+          </p:cNvPr>
+          <p:cNvSpPr/>
+          <p:nvPr/>
+        </p:nvSpPr>
+        <p:spPr>
+          <a:xfrm>
+            <a:off x="777240" y="2194560"/>
+            <a:ext cx="502920" cy="201168"/>
+          </a:xfrm>
+          <a:prstGeom prst="rect">
+            <a:avLst/>
+          </a:prstGeom>
+          <a:noFill/>
+          <a:ln/>
+        </p:spPr>
+        <p:txBody>
+          <a:bodyPr wrap="square" lIns="0" tIns="0" rIns="0" bIns="0" rtlCol="0" anchor="ctr"/>
+          <a:lstStyle/>
+          <a:p>
+            <a:pPr marL="0" indent="0" algn="ctr">
+              <a:buNone/>
+            </a:pPr>
+            <a:r>
+              <a:rPr lang="en-US" sz="1400" b="1" dirty="0">
+                <a:solidFill>
+                  <a:srgbClr val="FFFFFF"/>
+                </a:solidFill>
+                <a:latin typeface="Aptos" pitchFamily="34" charset="0"/>
+                <a:ea typeface="Aptos" pitchFamily="34" charset="-122"/>
+                <a:cs typeface="Aptos" pitchFamily="34" charset="-120"/>
+              </a:rPr>
+              <a:t>2</a:t>
+            </a:r>
+            <a:endParaRPr lang="en-US" sz="1400" dirty="0"/>
+          </a:p>
+        </p:txBody>
+      </p:sp>
+      <p:sp>
+        <p:nvSpPr>
+          <p:cNvPr id="10" name="Text 8">
+            <a:extLst>
+              <a:ext uri="{FF2B5EF4-FFF2-40B4-BE49-F238E27FC236}">
+                <a16:creationId xmlns:a16="http://schemas.microsoft.com/office/drawing/2014/main" id="{62C8286B-0F76-6A62-DD66-B21C1BBE3B05}"/>
+              </a:ext>
+            </a:extLst>
+          </p:cNvPr>
+          <p:cNvSpPr/>
+          <p:nvPr/>
+        </p:nvSpPr>
+        <p:spPr>
+          <a:xfrm>
+            <a:off x="1508760" y="2103120"/>
+            <a:ext cx="2926080" cy="256032"/>
+          </a:xfrm>
+          <a:prstGeom prst="rect">
+            <a:avLst/>
+          </a:prstGeom>
+          <a:noFill/>
+          <a:ln/>
+        </p:spPr>
+        <p:txBody>
+          <a:bodyPr wrap="square" lIns="0" tIns="0" rIns="0" bIns="0" rtlCol="0" anchor="ctr"/>
+          <a:lstStyle/>
+          <a:p>
+            <a:pPr marL="0" indent="0">
+              <a:buNone/>
+            </a:pPr>
+            <a:r>
+              <a:rPr lang="en-US" sz="2000" b="1" dirty="0">
+                <a:solidFill>
+                  <a:srgbClr val="16324F"/>
+                </a:solidFill>
+                <a:latin typeface="Aptos" pitchFamily="34" charset="0"/>
+                <a:ea typeface="Aptos" pitchFamily="34" charset="-122"/>
+                <a:cs typeface="Aptos" pitchFamily="34" charset="-120"/>
+              </a:rPr>
+              <a:t>Naive 48→12 kHz</a:t>
+            </a:r>
+            <a:endParaRPr lang="en-US" sz="2000" dirty="0"/>
+          </a:p>
+        </p:txBody>
+      </p:sp>
+      <p:sp>
+        <p:nvSpPr>
+          <p:cNvPr id="12" name="Shape 10">
+            <a:extLst>
+              <a:ext uri="{FF2B5EF4-FFF2-40B4-BE49-F238E27FC236}">
+                <a16:creationId xmlns:a16="http://schemas.microsoft.com/office/drawing/2014/main" id="{4224055A-4AEB-DC22-9758-CF5DE50A08F1}"/>
+              </a:ext>
+            </a:extLst>
+          </p:cNvPr>
+          <p:cNvSpPr/>
+          <p:nvPr/>
+        </p:nvSpPr>
+        <p:spPr>
+          <a:xfrm>
+            <a:off x="777240" y="2916936"/>
+            <a:ext cx="502920" cy="502920"/>
+          </a:xfrm>
+          <a:prstGeom prst="ellipse">
+            <a:avLst/>
+          </a:prstGeom>
+          <a:solidFill>
+            <a:srgbClr val="2C8C6B"/>
+          </a:solidFill>
+          <a:ln w="12700">
+            <a:solidFill>
+              <a:srgbClr val="FFFFFF"/>
+            </a:solidFill>
+            <a:prstDash val="solid"/>
+          </a:ln>
+        </p:spPr>
+        <p:txBody>
+          <a:bodyPr/>
+          <a:lstStyle/>
+          <a:p>
+            <a:endParaRPr lang="en-US"/>
+          </a:p>
+        </p:txBody>
+      </p:sp>
+      <p:sp>
+        <p:nvSpPr>
+          <p:cNvPr id="13" name="Text 11">
+            <a:extLst>
+              <a:ext uri="{FF2B5EF4-FFF2-40B4-BE49-F238E27FC236}">
+                <a16:creationId xmlns:a16="http://schemas.microsoft.com/office/drawing/2014/main" id="{2428B322-F1DC-69F6-1AE0-44C9CF3C14F4}"/>
+              </a:ext>
+            </a:extLst>
+          </p:cNvPr>
+          <p:cNvSpPr/>
+          <p:nvPr/>
+        </p:nvSpPr>
+        <p:spPr>
+          <a:xfrm>
+            <a:off x="777240" y="3035808"/>
+            <a:ext cx="502920" cy="201168"/>
+          </a:xfrm>
+          <a:prstGeom prst="rect">
+            <a:avLst/>
+          </a:prstGeom>
+          <a:noFill/>
+          <a:ln/>
+        </p:spPr>
+        <p:txBody>
+          <a:bodyPr wrap="square" lIns="0" tIns="0" rIns="0" bIns="0" rtlCol="0" anchor="ctr"/>
+          <a:lstStyle/>
+          <a:p>
+            <a:pPr marL="0" indent="0" algn="ctr">
+              <a:buNone/>
+            </a:pPr>
+            <a:r>
+              <a:rPr lang="en-US" sz="1400" b="1" dirty="0">
+                <a:solidFill>
+                  <a:srgbClr val="FFFFFF"/>
+                </a:solidFill>
+                <a:latin typeface="Aptos" pitchFamily="34" charset="0"/>
+                <a:ea typeface="Aptos" pitchFamily="34" charset="-122"/>
+                <a:cs typeface="Aptos" pitchFamily="34" charset="-120"/>
+              </a:rPr>
+              <a:t>3</a:t>
+            </a:r>
+            <a:endParaRPr lang="en-US" sz="1400" dirty="0"/>
+          </a:p>
+        </p:txBody>
+      </p:sp>
+      <p:sp>
+        <p:nvSpPr>
+          <p:cNvPr id="14" name="Text 12">
+            <a:extLst>
+              <a:ext uri="{FF2B5EF4-FFF2-40B4-BE49-F238E27FC236}">
+                <a16:creationId xmlns:a16="http://schemas.microsoft.com/office/drawing/2014/main" id="{020EFC7E-AD20-AFF5-0F16-B1774E9BF8CB}"/>
+              </a:ext>
+            </a:extLst>
+          </p:cNvPr>
+          <p:cNvSpPr/>
+          <p:nvPr/>
+        </p:nvSpPr>
+        <p:spPr>
+          <a:xfrm>
+            <a:off x="1508760" y="2944368"/>
+            <a:ext cx="2926080" cy="256032"/>
+          </a:xfrm>
+          <a:prstGeom prst="rect">
+            <a:avLst/>
+          </a:prstGeom>
+          <a:noFill/>
+          <a:ln/>
+        </p:spPr>
+        <p:txBody>
+          <a:bodyPr wrap="square" lIns="0" tIns="0" rIns="0" bIns="0" rtlCol="0" anchor="ctr"/>
+          <a:lstStyle/>
+          <a:p>
+            <a:pPr marL="0" indent="0">
+              <a:buNone/>
+            </a:pPr>
+            <a:r>
+              <a:rPr lang="en-US" sz="2000" b="1" dirty="0">
+                <a:solidFill>
+                  <a:srgbClr val="16324F"/>
+                </a:solidFill>
+                <a:latin typeface="Aptos" pitchFamily="34" charset="0"/>
+                <a:ea typeface="Aptos" pitchFamily="34" charset="-122"/>
+                <a:cs typeface="Aptos" pitchFamily="34" charset="-120"/>
+              </a:rPr>
+              <a:t>Filtered 48→12 kHz</a:t>
+            </a:r>
+            <a:endParaRPr lang="en-US" sz="2000" dirty="0"/>
+          </a:p>
+        </p:txBody>
+      </p:sp>
+      <p:sp>
+        <p:nvSpPr>
+          <p:cNvPr id="16" name="Shape 14">
+            <a:extLst>
+              <a:ext uri="{FF2B5EF4-FFF2-40B4-BE49-F238E27FC236}">
+                <a16:creationId xmlns:a16="http://schemas.microsoft.com/office/drawing/2014/main" id="{5D3CB554-4087-87C2-A72F-5D935486DE13}"/>
+              </a:ext>
+            </a:extLst>
+          </p:cNvPr>
+          <p:cNvSpPr/>
+          <p:nvPr/>
+        </p:nvSpPr>
+        <p:spPr>
+          <a:xfrm>
+            <a:off x="777240" y="3758184"/>
+            <a:ext cx="502920" cy="502920"/>
+          </a:xfrm>
+          <a:prstGeom prst="ellipse">
+            <a:avLst/>
+          </a:prstGeom>
+          <a:solidFill>
+            <a:srgbClr val="F28E2B"/>
+          </a:solidFill>
+          <a:ln w="12700">
+            <a:solidFill>
+              <a:srgbClr val="FFFFFF"/>
+            </a:solidFill>
+            <a:prstDash val="solid"/>
+          </a:ln>
+        </p:spPr>
+        <p:txBody>
+          <a:bodyPr/>
+          <a:lstStyle/>
+          <a:p>
+            <a:endParaRPr lang="en-US"/>
+          </a:p>
+        </p:txBody>
+      </p:sp>
+      <p:sp>
+        <p:nvSpPr>
+          <p:cNvPr id="17" name="Text 15">
+            <a:extLst>
+              <a:ext uri="{FF2B5EF4-FFF2-40B4-BE49-F238E27FC236}">
+                <a16:creationId xmlns:a16="http://schemas.microsoft.com/office/drawing/2014/main" id="{7803718D-6D50-0658-4E6C-736530F557E0}"/>
+              </a:ext>
+            </a:extLst>
+          </p:cNvPr>
+          <p:cNvSpPr/>
+          <p:nvPr/>
+        </p:nvSpPr>
+        <p:spPr>
+          <a:xfrm>
+            <a:off x="777240" y="3877056"/>
+            <a:ext cx="502920" cy="201168"/>
+          </a:xfrm>
+          <a:prstGeom prst="rect">
+            <a:avLst/>
+          </a:prstGeom>
+          <a:noFill/>
+          <a:ln/>
+        </p:spPr>
+        <p:txBody>
+          <a:bodyPr wrap="square" lIns="0" tIns="0" rIns="0" bIns="0" rtlCol="0" anchor="ctr"/>
+          <a:lstStyle/>
+          <a:p>
+            <a:pPr marL="0" indent="0" algn="ctr">
+              <a:buNone/>
+            </a:pPr>
+            <a:r>
+              <a:rPr lang="en-US" sz="1400" b="1" dirty="0">
+                <a:solidFill>
+                  <a:srgbClr val="FFFFFF"/>
+                </a:solidFill>
+                <a:latin typeface="Aptos" pitchFamily="34" charset="0"/>
+                <a:ea typeface="Aptos" pitchFamily="34" charset="-122"/>
+                <a:cs typeface="Aptos" pitchFamily="34" charset="-120"/>
+              </a:rPr>
+              <a:t>4</a:t>
+            </a:r>
+            <a:endParaRPr lang="en-US" sz="1400" dirty="0"/>
+          </a:p>
+        </p:txBody>
+      </p:sp>
+      <p:sp>
+        <p:nvSpPr>
+          <p:cNvPr id="18" name="Text 16">
+            <a:extLst>
+              <a:ext uri="{FF2B5EF4-FFF2-40B4-BE49-F238E27FC236}">
+                <a16:creationId xmlns:a16="http://schemas.microsoft.com/office/drawing/2014/main" id="{3B9C1E35-6A43-E2F2-4520-444B6E7A9961}"/>
+              </a:ext>
+            </a:extLst>
+          </p:cNvPr>
+          <p:cNvSpPr/>
+          <p:nvPr/>
+        </p:nvSpPr>
+        <p:spPr>
+          <a:xfrm>
+            <a:off x="1508760" y="3785616"/>
+            <a:ext cx="2926080" cy="256032"/>
+          </a:xfrm>
+          <a:prstGeom prst="rect">
+            <a:avLst/>
+          </a:prstGeom>
+          <a:noFill/>
+          <a:ln/>
+        </p:spPr>
+        <p:txBody>
+          <a:bodyPr wrap="square" lIns="0" tIns="0" rIns="0" bIns="0" rtlCol="0" anchor="ctr"/>
+          <a:lstStyle/>
+          <a:p>
+            <a:pPr marL="0" indent="0">
+              <a:buNone/>
+            </a:pPr>
+            <a:r>
+              <a:rPr lang="en-US" sz="2000" b="1" dirty="0">
+                <a:solidFill>
+                  <a:srgbClr val="16324F"/>
+                </a:solidFill>
+                <a:latin typeface="Aptos" pitchFamily="34" charset="0"/>
+                <a:ea typeface="Aptos" pitchFamily="34" charset="-122"/>
+                <a:cs typeface="Aptos" pitchFamily="34" charset="-120"/>
+              </a:rPr>
+              <a:t>8-bit quantized</a:t>
+            </a:r>
+            <a:endParaRPr lang="en-US" sz="2000" dirty="0"/>
+          </a:p>
+        </p:txBody>
+      </p:sp>
+      <p:sp>
+        <p:nvSpPr>
+          <p:cNvPr id="20" name="Shape 18">
+            <a:extLst>
+              <a:ext uri="{FF2B5EF4-FFF2-40B4-BE49-F238E27FC236}">
+                <a16:creationId xmlns:a16="http://schemas.microsoft.com/office/drawing/2014/main" id="{16D99859-5D27-2FD9-3BB5-2C8C0A5B4295}"/>
+              </a:ext>
+            </a:extLst>
+          </p:cNvPr>
+          <p:cNvSpPr/>
+          <p:nvPr/>
+        </p:nvSpPr>
+        <p:spPr>
+          <a:xfrm>
+            <a:off x="777240" y="4599432"/>
+            <a:ext cx="502920" cy="502920"/>
+          </a:xfrm>
+          <a:prstGeom prst="ellipse">
+            <a:avLst/>
+          </a:prstGeom>
+          <a:solidFill>
+            <a:srgbClr val="F28E2B"/>
+          </a:solidFill>
+          <a:ln w="12700">
+            <a:solidFill>
+              <a:srgbClr val="FFFFFF"/>
+            </a:solidFill>
+            <a:prstDash val="solid"/>
+          </a:ln>
+        </p:spPr>
+        <p:txBody>
+          <a:bodyPr/>
+          <a:lstStyle/>
+          <a:p>
+            <a:endParaRPr lang="en-US"/>
+          </a:p>
+        </p:txBody>
+      </p:sp>
+      <p:sp>
+        <p:nvSpPr>
+          <p:cNvPr id="21" name="Text 19">
+            <a:extLst>
+              <a:ext uri="{FF2B5EF4-FFF2-40B4-BE49-F238E27FC236}">
+                <a16:creationId xmlns:a16="http://schemas.microsoft.com/office/drawing/2014/main" id="{FF82A659-ED76-8102-E671-ACB8AADC0312}"/>
+              </a:ext>
+            </a:extLst>
+          </p:cNvPr>
+          <p:cNvSpPr/>
+          <p:nvPr/>
+        </p:nvSpPr>
+        <p:spPr>
+          <a:xfrm>
+            <a:off x="777240" y="4718304"/>
+            <a:ext cx="502920" cy="201168"/>
+          </a:xfrm>
+          <a:prstGeom prst="rect">
+            <a:avLst/>
+          </a:prstGeom>
+          <a:noFill/>
+          <a:ln/>
+        </p:spPr>
+        <p:txBody>
+          <a:bodyPr wrap="square" lIns="0" tIns="0" rIns="0" bIns="0" rtlCol="0" anchor="ctr"/>
+          <a:lstStyle/>
+          <a:p>
+            <a:pPr marL="0" indent="0" algn="ctr">
+              <a:buNone/>
+            </a:pPr>
+            <a:r>
+              <a:rPr lang="en-US" sz="1400" b="1" dirty="0">
+                <a:solidFill>
+                  <a:srgbClr val="FFFFFF"/>
+                </a:solidFill>
+                <a:latin typeface="Aptos" pitchFamily="34" charset="0"/>
+                <a:ea typeface="Aptos" pitchFamily="34" charset="-122"/>
+                <a:cs typeface="Aptos" pitchFamily="34" charset="-120"/>
+              </a:rPr>
+              <a:t>5</a:t>
+            </a:r>
+            <a:endParaRPr lang="en-US" sz="1400" dirty="0"/>
+          </a:p>
+        </p:txBody>
+      </p:sp>
+      <p:sp>
+        <p:nvSpPr>
+          <p:cNvPr id="22" name="Text 20">
+            <a:extLst>
+              <a:ext uri="{FF2B5EF4-FFF2-40B4-BE49-F238E27FC236}">
+                <a16:creationId xmlns:a16="http://schemas.microsoft.com/office/drawing/2014/main" id="{825453B2-C090-1685-1462-B784CAA5C70D}"/>
+              </a:ext>
+            </a:extLst>
+          </p:cNvPr>
+          <p:cNvSpPr/>
+          <p:nvPr/>
+        </p:nvSpPr>
+        <p:spPr>
+          <a:xfrm>
+            <a:off x="1508760" y="4626864"/>
+            <a:ext cx="2926080" cy="256032"/>
+          </a:xfrm>
+          <a:prstGeom prst="rect">
+            <a:avLst/>
+          </a:prstGeom>
+          <a:noFill/>
+          <a:ln/>
+        </p:spPr>
+        <p:txBody>
+          <a:bodyPr wrap="square" lIns="0" tIns="0" rIns="0" bIns="0" rtlCol="0" anchor="ctr"/>
+          <a:lstStyle/>
+          <a:p>
+            <a:pPr marL="0" indent="0">
+              <a:buNone/>
+            </a:pPr>
+            <a:r>
+              <a:rPr lang="en-US" sz="2000" b="1" dirty="0">
+                <a:solidFill>
+                  <a:srgbClr val="16324F"/>
+                </a:solidFill>
+                <a:latin typeface="Aptos" pitchFamily="34" charset="0"/>
+                <a:ea typeface="Aptos" pitchFamily="34" charset="-122"/>
+                <a:cs typeface="Aptos" pitchFamily="34" charset="-120"/>
+              </a:rPr>
+              <a:t>4-bit quantized</a:t>
+            </a:r>
+            <a:endParaRPr lang="en-US" sz="2000" dirty="0"/>
+          </a:p>
+        </p:txBody>
+      </p:sp>
+      <p:sp>
+        <p:nvSpPr>
+          <p:cNvPr id="24" name="Shape 22">
+            <a:extLst>
+              <a:ext uri="{FF2B5EF4-FFF2-40B4-BE49-F238E27FC236}">
+                <a16:creationId xmlns:a16="http://schemas.microsoft.com/office/drawing/2014/main" id="{CED2C40C-FE41-3644-015F-666D09CAAF76}"/>
+              </a:ext>
+            </a:extLst>
+          </p:cNvPr>
+          <p:cNvSpPr/>
+          <p:nvPr/>
+        </p:nvSpPr>
+        <p:spPr>
+          <a:xfrm>
+            <a:off x="7223760" y="5394960"/>
+            <a:ext cx="3840480" cy="594360"/>
+          </a:xfrm>
+          <a:prstGeom prst="roundRect">
+            <a:avLst>
+              <a:gd name="adj" fmla="val 10769"/>
+            </a:avLst>
+          </a:prstGeom>
+          <a:solidFill>
+            <a:srgbClr val="FFF7E8"/>
+          </a:solidFill>
+          <a:ln w="17780">
+            <a:solidFill>
+              <a:srgbClr val="C99A2E"/>
+            </a:solidFill>
+            <a:prstDash val="solid"/>
+          </a:ln>
+        </p:spPr>
+        <p:txBody>
+          <a:bodyPr/>
+          <a:lstStyle/>
+          <a:p>
+            <a:endParaRPr lang="en-US"/>
+          </a:p>
+        </p:txBody>
+      </p:sp>
+      <p:sp>
+        <p:nvSpPr>
+          <p:cNvPr id="25" name="Text 23">
+            <a:extLst>
+              <a:ext uri="{FF2B5EF4-FFF2-40B4-BE49-F238E27FC236}">
+                <a16:creationId xmlns:a16="http://schemas.microsoft.com/office/drawing/2014/main" id="{943B7CD6-107A-F6BB-F8A3-61212647E704}"/>
+              </a:ext>
+            </a:extLst>
+          </p:cNvPr>
+          <p:cNvSpPr/>
+          <p:nvPr/>
+        </p:nvSpPr>
+        <p:spPr>
+          <a:xfrm>
+            <a:off x="7370064" y="5504688"/>
+            <a:ext cx="3547872" cy="374904"/>
+          </a:xfrm>
+          <a:prstGeom prst="rect">
+            <a:avLst/>
+          </a:prstGeom>
+          <a:noFill/>
+          <a:ln/>
+        </p:spPr>
+        <p:txBody>
+          <a:bodyPr wrap="square" lIns="0" tIns="0" rIns="0" bIns="0" rtlCol="0" anchor="ctr"/>
+          <a:lstStyle/>
+          <a:p>
+            <a:pPr marL="0" indent="0" algn="ctr">
+              <a:buNone/>
+            </a:pPr>
+            <a:r>
+              <a:rPr lang="en-US" sz="1700" b="1" dirty="0">
+                <a:solidFill>
+                  <a:srgbClr val="70520B"/>
+                </a:solidFill>
+                <a:latin typeface="Aptos" pitchFamily="34" charset="0"/>
+                <a:ea typeface="Aptos" pitchFamily="34" charset="-122"/>
+                <a:cs typeface="Aptos" pitchFamily="34" charset="-120"/>
+              </a:rPr>
+              <a:t>Ask students to predict what changes before playing each file.</a:t>
+            </a:r>
+            <a:endParaRPr lang="en-US" sz="1700" dirty="0"/>
+          </a:p>
+        </p:txBody>
+      </p:sp>
+      <p:sp>
+        <p:nvSpPr>
+          <p:cNvPr id="26" name="Slide Number Placeholder 0">
+            <a:extLst>
+              <a:ext uri="{FF2B5EF4-FFF2-40B4-BE49-F238E27FC236}">
+                <a16:creationId xmlns:a16="http://schemas.microsoft.com/office/drawing/2014/main" id="{0057754A-19DE-6E49-DED1-B4451C2FEA82}"/>
+              </a:ext>
+            </a:extLst>
+          </p:cNvPr>
+          <p:cNvSpPr>
+            <a:spLocks noGrp="1"/>
+          </p:cNvSpPr>
+          <p:nvPr>
+            <p:ph type="sldNum" sz="quarter" idx="4294967295"/>
+          </p:nvPr>
+        </p:nvSpPr>
+        <p:spPr>
+          <a:xfrm>
+            <a:off x="11201400" y="6547104"/>
+            <a:ext cx="502920" cy="164592"/>
+          </a:xfrm>
+          <a:prstGeom prst="rect">
+            <a:avLst/>
+          </a:prstGeom>
+          <a:extLst>
+            <a:ext uri="{C572A759-6A51-4108-AA02-DFA0A04FC94B}">
+              <ma14:wrappingTextBoxFlag xmlns="" xmlns:ma14="http://schemas.microsoft.com/office/mac/drawingml/2011/main" val="0"/>
+            </a:ext>
+          </a:extLst>
+        </p:spPr>
+        <p:txBody>
+          <a:bodyPr lIns="0" tIns="0" rIns="0" bIns="0"/>
+          <a:lstStyle>
+            <a:lvl1pPr>
+              <a:defRPr sz="900">
+                <a:solidFill>
+                  <a:srgbClr val="7B8790"/>
+                </a:solidFill>
+                <a:latin typeface="Aptos"/>
+                <a:ea typeface="Aptos"/>
+                <a:cs typeface="Aptos"/>
+              </a:defRPr>
+            </a:lvl1pPr>
+          </a:lstStyle>
+          <a:p>
+            <a:pPr algn="r"/>
+            <a:fld id="{F7021451-1387-4CA6-816F-3879F97B5CBC}" type="slidenum">
+              <a:rPr lang="en-US" b="0"/>
+              <a:t>22</a:t>
+            </a:fld>
+            <a:endParaRPr lang="en-US"/>
+          </a:p>
+        </p:txBody>
+      </p:sp>
+    </p:spTree>
+    <p:extLst>
+      <p:ext uri="{BB962C8B-B14F-4D97-AF65-F5344CB8AC3E}">
+        <p14:creationId xmlns:p14="http://schemas.microsoft.com/office/powerpoint/2010/main" val="3502880575"/>
+      </p:ext>
+    </p:extLst>
+  </p:cSld>
+  <p:clrMapOvr>
+    <a:masterClrMapping/>
+  </p:clrMapOvr>
+</p:sld>
+</file>
+
+<file path=ppt/slides/slide23.xml><?xml version="1.0" encoding="utf-8"?>
 <p:sld xmlns:a="http://schemas.openxmlformats.org/drawingml/2006/main" xmlns:r="http://schemas.openxmlformats.org/officeDocument/2006/relationships" xmlns:p="http://schemas.openxmlformats.org/presentationml/2006/main">
   <p:cSld name="Slide 20">
     <p:spTree>
@@ -9501,7 +10563,7 @@
           </a:prstGeom>
           <a:extLst>
             <a:ext uri="{C572A759-6A51-4108-AA02-DFA0A04FC94B}">
-              <ma14:wrappingTextBoxFlag xmlns="" xmlns:ma14="http://schemas.microsoft.com/office/mac/drawingml/2011/main" val="0"/>
+              <ma14:wrappingTextBoxFlag xmlns:ma14="http://schemas.microsoft.com/office/mac/drawingml/2011/main" xmlns="" val="0"/>
             </a:ext>
           </a:extLst>
         </p:spPr>
@@ -9523,7 +10585,7 @@
             <a:pPr algn="r"/>
             <a:fld id="{F7021451-1387-4CA6-816F-3879F97B5CBC}" type="slidenum">
               <a:rPr lang="en-US" b="0"/>
-              <a:t>22</a:t>
+              <a:t>23</a:t>
             </a:fld>
             <a:endParaRPr lang="en-US"/>
           </a:p>
@@ -9537,7 +10599,7 @@
 </p:sld>
 </file>
 
-<file path=ppt/slides/slide23.xml><?xml version="1.0" encoding="utf-8"?>
+<file path=ppt/slides/slide24.xml><?xml version="1.0" encoding="utf-8"?>
 <p:sld xmlns:a="http://schemas.openxmlformats.org/drawingml/2006/main" xmlns:r="http://schemas.openxmlformats.org/officeDocument/2006/relationships" xmlns:p="http://schemas.openxmlformats.org/presentationml/2006/main">
   <p:cSld name="Slide 21">
     <p:spTree>
@@ -9778,7 +10840,7 @@
           </a:prstGeom>
           <a:extLst>
             <a:ext uri="{C572A759-6A51-4108-AA02-DFA0A04FC94B}">
-              <ma14:wrappingTextBoxFlag xmlns="" xmlns:ma14="http://schemas.microsoft.com/office/mac/drawingml/2011/main" val="0"/>
+              <ma14:wrappingTextBoxFlag xmlns:ma14="http://schemas.microsoft.com/office/mac/drawingml/2011/main" xmlns="" val="0"/>
             </a:ext>
           </a:extLst>
         </p:spPr>
@@ -9800,7 +10862,7 @@
             <a:pPr algn="r"/>
             <a:fld id="{F7021451-1387-4CA6-816F-3879F97B5CBC}" type="slidenum">
               <a:rPr lang="en-US" b="0"/>
-              <a:t>23</a:t>
+              <a:t>24</a:t>
             </a:fld>
             <a:endParaRPr lang="en-US"/>
           </a:p>
@@ -9814,7 +10876,7 @@
 </p:sld>
 </file>
 
-<file path=ppt/slides/slide24.xml><?xml version="1.0" encoding="utf-8"?>
+<file path=ppt/slides/slide25.xml><?xml version="1.0" encoding="utf-8"?>
 <p:sld xmlns:a="http://schemas.openxmlformats.org/drawingml/2006/main" xmlns:r="http://schemas.openxmlformats.org/officeDocument/2006/relationships" xmlns:p="http://schemas.openxmlformats.org/presentationml/2006/main">
   <p:cSld name="Slide 22">
     <p:spTree>
@@ -10103,7 +11165,7 @@
           </a:prstGeom>
           <a:extLst>
             <a:ext uri="{C572A759-6A51-4108-AA02-DFA0A04FC94B}">
-              <ma14:wrappingTextBoxFlag xmlns="" xmlns:ma14="http://schemas.microsoft.com/office/mac/drawingml/2011/main" val="0"/>
+              <ma14:wrappingTextBoxFlag xmlns:ma14="http://schemas.microsoft.com/office/mac/drawingml/2011/main" xmlns="" val="0"/>
             </a:ext>
           </a:extLst>
         </p:spPr>
@@ -10125,7 +11187,7 @@
             <a:pPr algn="r"/>
             <a:fld id="{F7021451-1387-4CA6-816F-3879F97B5CBC}" type="slidenum">
               <a:rPr lang="en-US" b="0"/>
-              <a:t>24</a:t>
+              <a:t>25</a:t>
             </a:fld>
             <a:endParaRPr lang="en-US"/>
           </a:p>
@@ -10139,7 +11201,7 @@
 </p:sld>
 </file>
 
-<file path=ppt/slides/slide25.xml><?xml version="1.0" encoding="utf-8"?>
+<file path=ppt/slides/slide26.xml><?xml version="1.0" encoding="utf-8"?>
 <p:sld xmlns:a="http://schemas.openxmlformats.org/drawingml/2006/main" xmlns:r="http://schemas.openxmlformats.org/officeDocument/2006/relationships" xmlns:p="http://schemas.openxmlformats.org/presentationml/2006/main">
   <p:cSld name="Slide 23">
     <p:spTree>
@@ -10494,7 +11556,7 @@
           </a:prstGeom>
           <a:extLst>
             <a:ext uri="{C572A759-6A51-4108-AA02-DFA0A04FC94B}">
-              <ma14:wrappingTextBoxFlag xmlns="" xmlns:ma14="http://schemas.microsoft.com/office/mac/drawingml/2011/main" val="0"/>
+              <ma14:wrappingTextBoxFlag xmlns:ma14="http://schemas.microsoft.com/office/mac/drawingml/2011/main" xmlns="" val="0"/>
             </a:ext>
           </a:extLst>
         </p:spPr>
@@ -10516,7 +11578,7 @@
             <a:pPr algn="r"/>
             <a:fld id="{F7021451-1387-4CA6-816F-3879F97B5CBC}" type="slidenum">
               <a:rPr lang="en-US" b="0"/>
-              <a:t>25</a:t>
+              <a:t>26</a:t>
             </a:fld>
             <a:endParaRPr lang="en-US"/>
           </a:p>
@@ -10530,7 +11592,7 @@
 </p:sld>
 </file>
 
-<file path=ppt/slides/slide26.xml><?xml version="1.0" encoding="utf-8"?>
+<file path=ppt/slides/slide27.xml><?xml version="1.0" encoding="utf-8"?>
 <p:sld xmlns:a="http://schemas.openxmlformats.org/drawingml/2006/main" xmlns:r="http://schemas.openxmlformats.org/officeDocument/2006/relationships" xmlns:p="http://schemas.openxmlformats.org/presentationml/2006/main">
   <p:cSld>
     <p:spTree>
@@ -10990,7 +12052,7 @@
           </a:prstGeom>
           <a:extLst>
             <a:ext uri="{C572A759-6A51-4108-AA02-DFA0A04FC94B}">
-              <ma14:wrappingTextBoxFlag xmlns:ma14="http://schemas.microsoft.com/office/mac/drawingml/2011/main" xmlns="" val="0"/>
+              <ma14:wrappingTextBoxFlag xmlns="" xmlns:ma14="http://schemas.microsoft.com/office/mac/drawingml/2011/main" val="0"/>
             </a:ext>
           </a:extLst>
         </p:spPr>
@@ -11012,7 +12074,7 @@
             <a:pPr algn="r"/>
             <a:fld id="{F7021451-1387-4CA6-816F-3879F97B5CBC}" type="slidenum">
               <a:rPr lang="en-US" b="0"/>
-              <a:t>26</a:t>
+              <a:t>27</a:t>
             </a:fld>
             <a:endParaRPr lang="en-US"/>
           </a:p>
@@ -11031,7 +12093,7 @@
 </p:sld>
 </file>
 
-<file path=ppt/slides/slide27.xml><?xml version="1.0" encoding="utf-8"?>
+<file path=ppt/slides/slide28.xml><?xml version="1.0" encoding="utf-8"?>
 <p:sld xmlns:a="http://schemas.openxmlformats.org/drawingml/2006/main" xmlns:r="http://schemas.openxmlformats.org/officeDocument/2006/relationships" xmlns:p="http://schemas.openxmlformats.org/presentationml/2006/main">
   <p:cSld name="Slide 24">
     <p:spTree>
@@ -11355,7 +12417,7 @@
           </a:prstGeom>
           <a:extLst>
             <a:ext uri="{C572A759-6A51-4108-AA02-DFA0A04FC94B}">
-              <ma14:wrappingTextBoxFlag xmlns="" xmlns:ma14="http://schemas.microsoft.com/office/mac/drawingml/2011/main" val="0"/>
+              <ma14:wrappingTextBoxFlag xmlns:ma14="http://schemas.microsoft.com/office/mac/drawingml/2011/main" xmlns="" val="0"/>
             </a:ext>
           </a:extLst>
         </p:spPr>
@@ -11377,7 +12439,7 @@
             <a:pPr algn="r"/>
             <a:fld id="{F7021451-1387-4CA6-816F-3879F97B5CBC}" type="slidenum">
               <a:rPr lang="en-US" b="0"/>
-              <a:t>27</a:t>
+              <a:t>28</a:t>
             </a:fld>
             <a:endParaRPr lang="en-US"/>
           </a:p>
@@ -11768,7 +12830,7 @@
           </a:prstGeom>
           <a:extLst>
             <a:ext uri="{C572A759-6A51-4108-AA02-DFA0A04FC94B}">
-              <ma14:wrappingTextBoxFlag xmlns="" xmlns:ma14="http://schemas.microsoft.com/office/mac/drawingml/2011/main" val="0"/>
+              <ma14:wrappingTextBoxFlag xmlns:ma14="http://schemas.microsoft.com/office/mac/drawingml/2011/main" xmlns="" val="0"/>
             </a:ext>
           </a:extLst>
         </p:spPr>
@@ -12031,7 +13093,7 @@
           </a:prstGeom>
           <a:extLst>
             <a:ext uri="{C572A759-6A51-4108-AA02-DFA0A04FC94B}">
-              <ma14:wrappingTextBoxFlag xmlns="" xmlns:ma14="http://schemas.microsoft.com/office/mac/drawingml/2011/main" val="0"/>
+              <ma14:wrappingTextBoxFlag xmlns:ma14="http://schemas.microsoft.com/office/mac/drawingml/2011/main" xmlns="" val="0"/>
             </a:ext>
           </a:extLst>
         </p:spPr>
@@ -12436,7 +13498,7 @@
           </a:prstGeom>
           <a:extLst>
             <a:ext uri="{C572A759-6A51-4108-AA02-DFA0A04FC94B}">
-              <ma14:wrappingTextBoxFlag xmlns="" xmlns:ma14="http://schemas.microsoft.com/office/mac/drawingml/2011/main" val="0"/>
+              <ma14:wrappingTextBoxFlag xmlns:ma14="http://schemas.microsoft.com/office/mac/drawingml/2011/main" xmlns="" val="0"/>
             </a:ext>
           </a:extLst>
         </p:spPr>
@@ -12684,7 +13746,7 @@
           </a:prstGeom>
           <a:extLst>
             <a:ext uri="{C572A759-6A51-4108-AA02-DFA0A04FC94B}">
-              <ma14:wrappingTextBoxFlag xmlns:ma14="http://schemas.microsoft.com/office/mac/drawingml/2011/main" xmlns="" val="0"/>
+              <ma14:wrappingTextBoxFlag xmlns="" xmlns:ma14="http://schemas.microsoft.com/office/mac/drawingml/2011/main" val="0"/>
             </a:ext>
           </a:extLst>
         </p:spPr>
@@ -13009,7 +14071,7 @@
           </a:prstGeom>
           <a:extLst>
             <a:ext uri="{C572A759-6A51-4108-AA02-DFA0A04FC94B}">
-              <ma14:wrappingTextBoxFlag xmlns="" xmlns:ma14="http://schemas.microsoft.com/office/mac/drawingml/2011/main" val="0"/>
+              <ma14:wrappingTextBoxFlag xmlns:ma14="http://schemas.microsoft.com/office/mac/drawingml/2011/main" xmlns="" val="0"/>
             </a:ext>
           </a:extLst>
         </p:spPr>
@@ -13328,7 +14390,7 @@
           </a:prstGeom>
           <a:extLst>
             <a:ext uri="{C572A759-6A51-4108-AA02-DFA0A04FC94B}">
-              <ma14:wrappingTextBoxFlag xmlns="" xmlns:ma14="http://schemas.microsoft.com/office/mac/drawingml/2011/main" val="0"/>
+              <ma14:wrappingTextBoxFlag xmlns:ma14="http://schemas.microsoft.com/office/mac/drawingml/2011/main" xmlns="" val="0"/>
             </a:ext>
           </a:extLst>
         </p:spPr>
@@ -13503,7 +14565,7 @@
           </a:prstGeom>
           <a:extLst>
             <a:ext uri="{C572A759-6A51-4108-AA02-DFA0A04FC94B}">
-              <ma14:wrappingTextBoxFlag xmlns="" xmlns:ma14="http://schemas.microsoft.com/office/mac/drawingml/2011/main" val="0"/>
+              <ma14:wrappingTextBoxFlag xmlns:ma14="http://schemas.microsoft.com/office/mac/drawingml/2011/main" xmlns="" val="0"/>
             </a:ext>
           </a:extLst>
         </p:spPr>

</xml_diff>